<commit_message>
Fill team name (19일의 월요일) in docs and deck
Co-Authored-By: Claude Fable 5.1 <noreply@anthropic.com>
Claude-Session: https://claude.ai/code/session_01JBzjJAPnJuvitLsm42fE9B
</commit_message>
<xml_diff>
--- a/reports/slides/bloom_deck.pptx
+++ b/reports/slides/bloom_deck.pptx
@@ -118,33 +118,33 @@
   <p:extLst>
     <p:ext uri="{521415D9-36F7-43E2-AB2F-B90AF26B5E84}">
       <p14:sectionLst xmlns:p14="http://schemas.microsoft.com/office/powerpoint/2010/main">
-        <p14:section name="도입" id="{74184711-b6f2-3587-61ec-8d11c26d8ec6}">
+        <p14:section name="도입" id="{a5fec07d-2744-e860-67a1-6b687526173b}">
           <p14:sldIdLst>
             <p14:sldId id="256"/>
             <p14:sldId id="257"/>
           </p14:sldIdLst>
         </p14:section>
-        <p14:section name="데이터" id="{d0838bab-fd72-2109-6b8b-2bd278c273a6}">
+        <p14:section name="데이터" id="{a38a3751-fc67-8269-8939-7cb4ab877fdd}">
           <p14:sldIdLst>
             <p14:sldId id="258"/>
             <p14:sldId id="259"/>
           </p14:sldIdLst>
         </p14:section>
-        <p14:section name="방법" id="{fcb330c0-6971-e148-2dcf-f4f8451ee459}">
+        <p14:section name="방법" id="{54f78620-9e87-1462-f71c-778c63a4c745}">
           <p14:sldIdLst>
             <p14:sldId id="260"/>
             <p14:sldId id="261"/>
             <p14:sldId id="262"/>
           </p14:sldIdLst>
         </p14:section>
-        <p14:section name="결과" id="{1e3c1419-d4da-5131-50e0-5946b14701bf}">
+        <p14:section name="결과" id="{d5f893c7-5b18-2669-5838-c6fb71964ec9}">
           <p14:sldIdLst>
             <p14:sldId id="263"/>
             <p14:sldId id="264"/>
             <p14:sldId id="265"/>
           </p14:sldIdLst>
         </p14:section>
-        <p14:section name="마무리" id="{4b99151a-410c-66f4-4718-e841140eb8f7}">
+        <p14:section name="마무리" id="{821fde9f-4bac-2a40-fb80-cd71acb9a4ef}">
           <p14:sldIdLst>
             <p14:sldId id="266"/>
             <p14:sldId id="267"/>
@@ -3198,7 +3198,7 @@
                   <a:schemeClr val="accent6"/>
                 </a:solidFill>
               </a:rPr>
-              <a:t>팀명: (기입)  ·  팀원: (기입)  ·  2026. 11.</a:t>
+              <a:t>팀명: 19일의 월요일  ·  팀원: (기입)  ·  2026. 11.</a:t>
             </a:r>
             <a:endParaRPr lang="en-US" sz="1600" dirty="0"/>
           </a:p>

</xml_diff>